<commit_message>
Adiciona resumo em Word com links e inclui referencia do Claude na bibliografia
</commit_message>
<xml_diff>
--- a/checkpoint4/apresentacao_cp4.pptx
+++ b/checkpoint4/apresentacao_cp4.pptx
@@ -4970,12 +4970,12 @@
         </p:nvSpPr>
         <p:spPr>
           <a:xfrm>
-            <a:off x="566928" y="1545336"/>
-            <a:ext cx="11045952" cy="658368"/>
+            <a:off x="566928" y="1463040"/>
+            <a:ext cx="11045952" cy="585216"/>
           </a:xfrm>
           <a:prstGeom prst="roundRect">
             <a:avLst>
-              <a:gd name="adj" fmla="val 6944"/>
+              <a:gd name="adj" fmla="val 7813"/>
             </a:avLst>
           </a:prstGeom>
           <a:solidFill>
@@ -4997,24 +4997,24 @@
         </p:nvSpPr>
         <p:spPr>
           <a:xfrm>
-            <a:off x="777240" y="1581912"/>
-            <a:ext cx="10607040" cy="585216"/>
-          </a:xfrm>
-          <a:prstGeom prst="rect">
-            <a:avLst/>
-          </a:prstGeom>
-          <a:noFill/>
-          <a:ln/>
-        </p:spPr>
-        <p:txBody>
-          <a:bodyPr wrap="square" lIns="0" tIns="0" rIns="0" bIns="0" rtlCol="0" anchor="ctr"/>
-          <a:lstStyle/>
-          <a:p>
-            <a:pPr indent="0" marL="0">
-              <a:buNone/>
-            </a:pPr>
-            <a:r>
-              <a:rPr lang="en-US" sz="1250" dirty="0">
+            <a:off x="777240" y="1490472"/>
+            <a:ext cx="10607040" cy="530352"/>
+          </a:xfrm>
+          <a:prstGeom prst="rect">
+            <a:avLst/>
+          </a:prstGeom>
+          <a:noFill/>
+          <a:ln/>
+        </p:spPr>
+        <p:txBody>
+          <a:bodyPr wrap="square" lIns="0" tIns="0" rIns="0" bIns="0" rtlCol="0" anchor="ctr"/>
+          <a:lstStyle/>
+          <a:p>
+            <a:pPr indent="0" marL="0">
+              <a:buNone/>
+            </a:pPr>
+            <a:r>
+              <a:rPr lang="en-US" sz="1150" dirty="0">
                 <a:solidFill>
                   <a:srgbClr val="1B2A3A"/>
                 </a:solidFill>
@@ -5024,7 +5024,7 @@
               </a:rPr>
               <a:t>BUSSAB, Wilson de O.; MORETTIN, Pedro A. Estatística básica. 9. ed. São Paulo: Saraiva, 2017.</a:t>
             </a:r>
-            <a:endParaRPr lang="en-US" sz="1250" dirty="0"/>
+            <a:endParaRPr lang="en-US" sz="1150" dirty="0"/>
           </a:p>
         </p:txBody>
       </p:sp>
@@ -5036,24 +5036,24 @@
         </p:nvSpPr>
         <p:spPr>
           <a:xfrm>
-            <a:off x="777240" y="2148840"/>
-            <a:ext cx="10607040" cy="585216"/>
-          </a:xfrm>
-          <a:prstGeom prst="rect">
-            <a:avLst/>
-          </a:prstGeom>
-          <a:noFill/>
-          <a:ln/>
-        </p:spPr>
-        <p:txBody>
-          <a:bodyPr wrap="square" lIns="0" tIns="0" rIns="0" bIns="0" rtlCol="0" anchor="ctr"/>
-          <a:lstStyle/>
-          <a:p>
-            <a:pPr indent="0" marL="0">
-              <a:buNone/>
-            </a:pPr>
-            <a:r>
-              <a:rPr lang="en-US" sz="1250" dirty="0">
+            <a:off x="777240" y="2002536"/>
+            <a:ext cx="10607040" cy="530352"/>
+          </a:xfrm>
+          <a:prstGeom prst="rect">
+            <a:avLst/>
+          </a:prstGeom>
+          <a:noFill/>
+          <a:ln/>
+        </p:spPr>
+        <p:txBody>
+          <a:bodyPr wrap="square" lIns="0" tIns="0" rIns="0" bIns="0" rtlCol="0" anchor="ctr"/>
+          <a:lstStyle/>
+          <a:p>
+            <a:pPr indent="0" marL="0">
+              <a:buNone/>
+            </a:pPr>
+            <a:r>
+              <a:rPr lang="en-US" sz="1150" dirty="0">
                 <a:solidFill>
                   <a:srgbClr val="1B2A3A"/>
                 </a:solidFill>
@@ -5063,7 +5063,7 @@
               </a:rPr>
               <a:t>MONTGOMERY, Douglas C.; RUNGER, George C. Estatística aplicada e probabilidade para engenheiros. 7. ed. Rio de Janeiro: LTC, 2021.</a:t>
             </a:r>
-            <a:endParaRPr lang="en-US" sz="1250" dirty="0"/>
+            <a:endParaRPr lang="en-US" sz="1150" dirty="0"/>
           </a:p>
         </p:txBody>
       </p:sp>
@@ -5075,12 +5075,12 @@
         </p:nvSpPr>
         <p:spPr>
           <a:xfrm>
-            <a:off x="566928" y="2679192"/>
-            <a:ext cx="11045952" cy="658368"/>
+            <a:off x="566928" y="2487168"/>
+            <a:ext cx="11045952" cy="585216"/>
           </a:xfrm>
           <a:prstGeom prst="roundRect">
             <a:avLst>
-              <a:gd name="adj" fmla="val 6944"/>
+              <a:gd name="adj" fmla="val 7813"/>
             </a:avLst>
           </a:prstGeom>
           <a:solidFill>
@@ -5102,24 +5102,24 @@
         </p:nvSpPr>
         <p:spPr>
           <a:xfrm>
-            <a:off x="777240" y="2715768"/>
-            <a:ext cx="10607040" cy="585216"/>
-          </a:xfrm>
-          <a:prstGeom prst="rect">
-            <a:avLst/>
-          </a:prstGeom>
-          <a:noFill/>
-          <a:ln/>
-        </p:spPr>
-        <p:txBody>
-          <a:bodyPr wrap="square" lIns="0" tIns="0" rIns="0" bIns="0" rtlCol="0" anchor="ctr"/>
-          <a:lstStyle/>
-          <a:p>
-            <a:pPr indent="0" marL="0">
-              <a:buNone/>
-            </a:pPr>
-            <a:r>
-              <a:rPr lang="en-US" sz="1250" dirty="0">
+            <a:off x="777240" y="2514600"/>
+            <a:ext cx="10607040" cy="530352"/>
+          </a:xfrm>
+          <a:prstGeom prst="rect">
+            <a:avLst/>
+          </a:prstGeom>
+          <a:noFill/>
+          <a:ln/>
+        </p:spPr>
+        <p:txBody>
+          <a:bodyPr wrap="square" lIns="0" tIns="0" rIns="0" bIns="0" rtlCol="0" anchor="ctr"/>
+          <a:lstStyle/>
+          <a:p>
+            <a:pPr indent="0" marL="0">
+              <a:buNone/>
+            </a:pPr>
+            <a:r>
+              <a:rPr lang="en-US" sz="1150" dirty="0">
                 <a:solidFill>
                   <a:srgbClr val="1B2A3A"/>
                 </a:solidFill>
@@ -5129,7 +5129,7 @@
               </a:rPr>
               <a:t>FÁVERO, Luiz Paulo; BELFIORE, Patrícia. Manual de análise de dados: estatística e modelagem multivariada. Rio de Janeiro: LTC, 2017.</a:t>
             </a:r>
-            <a:endParaRPr lang="en-US" sz="1250" dirty="0"/>
+            <a:endParaRPr lang="en-US" sz="1150" dirty="0"/>
           </a:p>
         </p:txBody>
       </p:sp>
@@ -5141,24 +5141,24 @@
         </p:nvSpPr>
         <p:spPr>
           <a:xfrm>
-            <a:off x="777240" y="3282696"/>
-            <a:ext cx="10607040" cy="585216"/>
-          </a:xfrm>
-          <a:prstGeom prst="rect">
-            <a:avLst/>
-          </a:prstGeom>
-          <a:noFill/>
-          <a:ln/>
-        </p:spPr>
-        <p:txBody>
-          <a:bodyPr wrap="square" lIns="0" tIns="0" rIns="0" bIns="0" rtlCol="0" anchor="ctr"/>
-          <a:lstStyle/>
-          <a:p>
-            <a:pPr indent="0" marL="0">
-              <a:buNone/>
-            </a:pPr>
-            <a:r>
-              <a:rPr lang="en-US" sz="1250" dirty="0">
+            <a:off x="777240" y="3026664"/>
+            <a:ext cx="10607040" cy="530352"/>
+          </a:xfrm>
+          <a:prstGeom prst="rect">
+            <a:avLst/>
+          </a:prstGeom>
+          <a:noFill/>
+          <a:ln/>
+        </p:spPr>
+        <p:txBody>
+          <a:bodyPr wrap="square" lIns="0" tIns="0" rIns="0" bIns="0" rtlCol="0" anchor="ctr"/>
+          <a:lstStyle/>
+          <a:p>
+            <a:pPr indent="0" marL="0">
+              <a:buNone/>
+            </a:pPr>
+            <a:r>
+              <a:rPr lang="en-US" sz="1150" dirty="0">
                 <a:solidFill>
                   <a:srgbClr val="1B2A3A"/>
                 </a:solidFill>
@@ -5168,7 +5168,7 @@
               </a:rPr>
               <a:t>JAMES, Gareth et al. An introduction to statistical learning: with applications in Python. Cham: Springer, 2023.</a:t>
             </a:r>
-            <a:endParaRPr lang="en-US" sz="1250" dirty="0"/>
+            <a:endParaRPr lang="en-US" sz="1150" dirty="0"/>
           </a:p>
         </p:txBody>
       </p:sp>
@@ -5180,12 +5180,12 @@
         </p:nvSpPr>
         <p:spPr>
           <a:xfrm>
-            <a:off x="566928" y="3813048"/>
-            <a:ext cx="11045952" cy="658368"/>
+            <a:off x="566928" y="3511296"/>
+            <a:ext cx="11045952" cy="585216"/>
           </a:xfrm>
           <a:prstGeom prst="roundRect">
             <a:avLst>
-              <a:gd name="adj" fmla="val 6944"/>
+              <a:gd name="adj" fmla="val 7813"/>
             </a:avLst>
           </a:prstGeom>
           <a:solidFill>
@@ -5207,24 +5207,24 @@
         </p:nvSpPr>
         <p:spPr>
           <a:xfrm>
-            <a:off x="777240" y="3849624"/>
-            <a:ext cx="10607040" cy="585216"/>
-          </a:xfrm>
-          <a:prstGeom prst="rect">
-            <a:avLst/>
-          </a:prstGeom>
-          <a:noFill/>
-          <a:ln/>
-        </p:spPr>
-        <p:txBody>
-          <a:bodyPr wrap="square" lIns="0" tIns="0" rIns="0" bIns="0" rtlCol="0" anchor="ctr"/>
-          <a:lstStyle/>
-          <a:p>
-            <a:pPr indent="0" marL="0">
-              <a:buNone/>
-            </a:pPr>
-            <a:r>
-              <a:rPr lang="en-US" sz="1250" dirty="0">
+            <a:off x="777240" y="3538728"/>
+            <a:ext cx="10607040" cy="530352"/>
+          </a:xfrm>
+          <a:prstGeom prst="rect">
+            <a:avLst/>
+          </a:prstGeom>
+          <a:noFill/>
+          <a:ln/>
+        </p:spPr>
+        <p:txBody>
+          <a:bodyPr wrap="square" lIns="0" tIns="0" rIns="0" bIns="0" rtlCol="0" anchor="ctr"/>
+          <a:lstStyle/>
+          <a:p>
+            <a:pPr indent="0" marL="0">
+              <a:buNone/>
+            </a:pPr>
+            <a:r>
+              <a:rPr lang="en-US" sz="1150" dirty="0">
                 <a:solidFill>
                   <a:srgbClr val="1B2A3A"/>
                 </a:solidFill>
@@ -5234,7 +5234,7 @@
               </a:rPr>
               <a:t>GÉRON, Aurélien. Mãos à obra: aprendizado de máquina com Scikit-Learn, Keras &amp; TensorFlow. 2. ed. Rio de Janeiro: Alta Books, 2021.</a:t>
             </a:r>
-            <a:endParaRPr lang="en-US" sz="1250" dirty="0"/>
+            <a:endParaRPr lang="en-US" sz="1150" dirty="0"/>
           </a:p>
         </p:txBody>
       </p:sp>
@@ -5246,24 +5246,24 @@
         </p:nvSpPr>
         <p:spPr>
           <a:xfrm>
-            <a:off x="777240" y="4416552"/>
-            <a:ext cx="10607040" cy="585216"/>
-          </a:xfrm>
-          <a:prstGeom prst="rect">
-            <a:avLst/>
-          </a:prstGeom>
-          <a:noFill/>
-          <a:ln/>
-        </p:spPr>
-        <p:txBody>
-          <a:bodyPr wrap="square" lIns="0" tIns="0" rIns="0" bIns="0" rtlCol="0" anchor="ctr"/>
-          <a:lstStyle/>
-          <a:p>
-            <a:pPr indent="0" marL="0">
-              <a:buNone/>
-            </a:pPr>
-            <a:r>
-              <a:rPr lang="en-US" sz="1250" dirty="0">
+            <a:off x="777240" y="4050792"/>
+            <a:ext cx="10607040" cy="530352"/>
+          </a:xfrm>
+          <a:prstGeom prst="rect">
+            <a:avLst/>
+          </a:prstGeom>
+          <a:noFill/>
+          <a:ln/>
+        </p:spPr>
+        <p:txBody>
+          <a:bodyPr wrap="square" lIns="0" tIns="0" rIns="0" bIns="0" rtlCol="0" anchor="ctr"/>
+          <a:lstStyle/>
+          <a:p>
+            <a:pPr indent="0" marL="0">
+              <a:buNone/>
+            </a:pPr>
+            <a:r>
+              <a:rPr lang="en-US" sz="1150" dirty="0">
                 <a:solidFill>
                   <a:srgbClr val="1B2A3A"/>
                 </a:solidFill>
@@ -5273,7 +5273,7 @@
               </a:rPr>
               <a:t>MCKINNEY, Wes. Python para análise de dados: tratamento de dados com Pandas, NumPy e Jupyter. 3. ed. São Paulo: Novatec, 2023.</a:t>
             </a:r>
-            <a:endParaRPr lang="en-US" sz="1250" dirty="0"/>
+            <a:endParaRPr lang="en-US" sz="1150" dirty="0"/>
           </a:p>
         </p:txBody>
       </p:sp>
@@ -5285,12 +5285,12 @@
         </p:nvSpPr>
         <p:spPr>
           <a:xfrm>
-            <a:off x="566928" y="4946904"/>
-            <a:ext cx="11045952" cy="658368"/>
+            <a:off x="566928" y="4535424"/>
+            <a:ext cx="11045952" cy="585216"/>
           </a:xfrm>
           <a:prstGeom prst="roundRect">
             <a:avLst>
-              <a:gd name="adj" fmla="val 6944"/>
+              <a:gd name="adj" fmla="val 7813"/>
             </a:avLst>
           </a:prstGeom>
           <a:solidFill>
@@ -5312,24 +5312,24 @@
         </p:nvSpPr>
         <p:spPr>
           <a:xfrm>
-            <a:off x="777240" y="4983480"/>
-            <a:ext cx="10607040" cy="585216"/>
-          </a:xfrm>
-          <a:prstGeom prst="rect">
-            <a:avLst/>
-          </a:prstGeom>
-          <a:noFill/>
-          <a:ln/>
-        </p:spPr>
-        <p:txBody>
-          <a:bodyPr wrap="square" lIns="0" tIns="0" rIns="0" bIns="0" rtlCol="0" anchor="ctr"/>
-          <a:lstStyle/>
-          <a:p>
-            <a:pPr indent="0" marL="0">
-              <a:buNone/>
-            </a:pPr>
-            <a:r>
-              <a:rPr lang="en-US" sz="1250" dirty="0">
+            <a:off x="777240" y="4562856"/>
+            <a:ext cx="10607040" cy="530352"/>
+          </a:xfrm>
+          <a:prstGeom prst="rect">
+            <a:avLst/>
+          </a:prstGeom>
+          <a:noFill/>
+          <a:ln/>
+        </p:spPr>
+        <p:txBody>
+          <a:bodyPr wrap="square" lIns="0" tIns="0" rIns="0" bIns="0" rtlCol="0" anchor="ctr"/>
+          <a:lstStyle/>
+          <a:p>
+            <a:pPr indent="0" marL="0">
+              <a:buNone/>
+            </a:pPr>
+            <a:r>
+              <a:rPr lang="en-US" sz="1150" dirty="0">
                 <a:solidFill>
                   <a:srgbClr val="1B2A3A"/>
                 </a:solidFill>
@@ -5339,7 +5339,7 @@
               </a:rPr>
               <a:t>NUMPY DEVELOPERS. NumPy documentation: random sampling (numpy.random). Disponível em: https://numpy.org/doc/stable/reference/random/index.html. Acesso em: 10 set. 2026.</a:t>
             </a:r>
-            <a:endParaRPr lang="en-US" sz="1250" dirty="0"/>
+            <a:endParaRPr lang="en-US" sz="1150" dirty="0"/>
           </a:p>
         </p:txBody>
       </p:sp>
@@ -5351,24 +5351,24 @@
         </p:nvSpPr>
         <p:spPr>
           <a:xfrm>
-            <a:off x="777240" y="5550408"/>
-            <a:ext cx="10607040" cy="585216"/>
-          </a:xfrm>
-          <a:prstGeom prst="rect">
-            <a:avLst/>
-          </a:prstGeom>
-          <a:noFill/>
-          <a:ln/>
-        </p:spPr>
-        <p:txBody>
-          <a:bodyPr wrap="square" lIns="0" tIns="0" rIns="0" bIns="0" rtlCol="0" anchor="ctr"/>
-          <a:lstStyle/>
-          <a:p>
-            <a:pPr indent="0" marL="0">
-              <a:buNone/>
-            </a:pPr>
-            <a:r>
-              <a:rPr lang="en-US" sz="1250" dirty="0">
+            <a:off x="777240" y="5074920"/>
+            <a:ext cx="10607040" cy="530352"/>
+          </a:xfrm>
+          <a:prstGeom prst="rect">
+            <a:avLst/>
+          </a:prstGeom>
+          <a:noFill/>
+          <a:ln/>
+        </p:spPr>
+        <p:txBody>
+          <a:bodyPr wrap="square" lIns="0" tIns="0" rIns="0" bIns="0" rtlCol="0" anchor="ctr"/>
+          <a:lstStyle/>
+          <a:p>
+            <a:pPr indent="0" marL="0">
+              <a:buNone/>
+            </a:pPr>
+            <a:r>
+              <a:rPr lang="en-US" sz="1150" dirty="0">
                 <a:solidFill>
                   <a:srgbClr val="1B2A3A"/>
                 </a:solidFill>
@@ -5378,13 +5378,79 @@
               </a:rPr>
               <a:t>SCIPY COMMUNITY. SciPy documentation: statistical functions (scipy.stats). Disponível em: https://docs.scipy.org/doc/scipy/reference/stats.html. Acesso em: 10 set. 2026.</a:t>
             </a:r>
-            <a:endParaRPr lang="en-US" sz="1250" dirty="0"/>
-          </a:p>
-        </p:txBody>
-      </p:sp>
-      <p:sp>
-        <p:nvSpPr>
-          <p:cNvPr id="18" name="Text 16"/>
+            <a:endParaRPr lang="en-US" sz="1150" dirty="0"/>
+          </a:p>
+        </p:txBody>
+      </p:sp>
+      <p:sp>
+        <p:nvSpPr>
+          <p:cNvPr id="18" name="Shape 16"/>
+          <p:cNvSpPr/>
+          <p:nvPr/>
+        </p:nvSpPr>
+        <p:spPr>
+          <a:xfrm>
+            <a:off x="566928" y="5559552"/>
+            <a:ext cx="11045952" cy="585216"/>
+          </a:xfrm>
+          <a:prstGeom prst="roundRect">
+            <a:avLst>
+              <a:gd name="adj" fmla="val 7813"/>
+            </a:avLst>
+          </a:prstGeom>
+          <a:solidFill>
+            <a:srgbClr val="F4F8FB"/>
+          </a:solidFill>
+          <a:ln w="12700">
+            <a:solidFill>
+              <a:srgbClr val="F4F8FB"/>
+            </a:solidFill>
+            <a:prstDash val="solid"/>
+          </a:ln>
+        </p:spPr>
+      </p:sp>
+      <p:sp>
+        <p:nvSpPr>
+          <p:cNvPr id="19" name="Text 17"/>
+          <p:cNvSpPr txBox="1"/>
+          <p:nvPr/>
+        </p:nvSpPr>
+        <p:spPr>
+          <a:xfrm>
+            <a:off x="777240" y="5586984"/>
+            <a:ext cx="10607040" cy="530352"/>
+          </a:xfrm>
+          <a:prstGeom prst="rect">
+            <a:avLst/>
+          </a:prstGeom>
+          <a:noFill/>
+          <a:ln/>
+        </p:spPr>
+        <p:txBody>
+          <a:bodyPr wrap="square" lIns="0" tIns="0" rIns="0" bIns="0" rtlCol="0" anchor="ctr"/>
+          <a:lstStyle/>
+          <a:p>
+            <a:pPr indent="0" marL="0">
+              <a:buNone/>
+            </a:pPr>
+            <a:r>
+              <a:rPr lang="en-US" sz="1150" dirty="0">
+                <a:solidFill>
+                  <a:srgbClr val="1B2A3A"/>
+                </a:solidFill>
+                <a:latin typeface="Calibri" pitchFamily="34" charset="0"/>
+                <a:ea typeface="Calibri" pitchFamily="34" charset="-122"/>
+                <a:cs typeface="Calibri" pitchFamily="34" charset="-120"/>
+              </a:rPr>
+              <a:t>ANTHROPIC. Claude: modelo de linguagem de grande porte. Versão Opus 5. San Francisco: Anthropic, 2026. Disponível em: https://claude.ai. Acesso em: 10 set. 2026. Utilizado como apoio na estruturação da apresentação e na revisão do código.</a:t>
+            </a:r>
+            <a:endParaRPr lang="en-US" sz="1150" dirty="0"/>
+          </a:p>
+        </p:txBody>
+      </p:sp>
+      <p:sp>
+        <p:nvSpPr>
+          <p:cNvPr id="20" name="Text 18"/>
           <p:cNvSpPr txBox="1"/>
           <p:nvPr/>
         </p:nvSpPr>

</xml_diff>

<commit_message>
Simplifica a linguagem dos slides, adiciona exemplos do dia a dia, reescreve o roteiro e inclui notebook para o Colab
</commit_message>
<xml_diff>
--- a/checkpoint4/apresentacao_cp4.pptx
+++ b/checkpoint4/apresentacao_cp4.pptx
@@ -2450,7 +2450,7 @@
                 <a:ea typeface="Calibri" pitchFamily="34" charset="-122"/>
                 <a:cs typeface="Calibri" pitchFamily="34" charset="-120"/>
               </a:rPr>
-              <a:t>Desempenho no conjunto de teste (300 entregas nunca vistas)</a:t>
+              <a:t>Testamos em 300 entregas que o modelo nunca tinha visto</a:t>
             </a:r>
             <a:endParaRPr lang="en-US" sz="1400" dirty="0"/>
           </a:p>
@@ -2933,7 +2933,7 @@
                 <a:ea typeface="Calibri" pitchFamily="34" charset="-122"/>
                 <a:cs typeface="Calibri" pitchFamily="34" charset="-120"/>
               </a:rPr>
-              <a:t>Precisão alta e recall moderado. Quando o modelo aponta atraso, quase sempre acerta, mas deixa passar parte dos atrasos limítrofes.</a:t>
+              <a:t>Quando o modelo avisa que vai atrasar, ele quase sempre acerta. O ponto fraco é deixar escapar algumas entregas que atrasaram por pouco.</a:t>
             </a:r>
             <a:endParaRPr lang="en-US" sz="1250" dirty="0"/>
           </a:p>
@@ -3392,7 +3392,7 @@
                 <a:ea typeface="Calibri" pitchFamily="34" charset="-122"/>
                 <a:cs typeface="Calibri" pitchFamily="34" charset="-120"/>
               </a:rPr>
-              <a:t>Com o risco calculado pedido a pedido, a operação consegue reforçar a frota, reroteirizar ou avisar o cliente antes que o prazo estoure.</a:t>
+              <a:t>Sabendo o risco de cada pedido antes de sair, a empresa pode mandar outro veículo, mudar a rota ou avisar o cliente antes do prazo estourar.</a:t>
             </a:r>
             <a:endParaRPr lang="en-US" sz="1250" dirty="0"/>
           </a:p>
@@ -3561,7 +3561,7 @@
                 <a:ea typeface="Calibri" pitchFamily="34" charset="-122"/>
                 <a:cs typeface="Calibri" pitchFamily="34" charset="-120"/>
               </a:rPr>
-              <a:t>20.000 sorteios por cenário para comparar decisões</a:t>
+              <a:t>Testando mudanças na operação antes de aplicá-las</a:t>
             </a:r>
             <a:endParaRPr lang="en-US" sz="1400" dirty="0"/>
           </a:p>
@@ -3815,7 +3815,7 @@
                 <a:ea typeface="Calibri" pitchFamily="34" charset="-122"/>
                 <a:cs typeface="Calibri" pitchFamily="34" charset="-120"/>
               </a:rPr>
-              <a:t>Queda de 17 pontos percentuais combinando roteirização automática e padronização da frota, o que representa cerca de 17 mil entregas atrasadas a menos a cada 100 mil.</a:t>
+              <a:t>Fazendo as duas mudanças juntas, o risco cai 17 pontos. Em cada 100 mil entregas, são cerca de 17 mil atrasos a menos.</a:t>
             </a:r>
             <a:endParaRPr lang="en-US" sz="1250" dirty="0"/>
           </a:p>
@@ -3900,7 +3900,7 @@
                 <a:ea typeface="Calibri" pitchFamily="34" charset="-122"/>
                 <a:cs typeface="Calibri" pitchFamily="34" charset="-120"/>
               </a:rPr>
-              <a:t>Neste caso, reduzir a média (μ) pesa mais do que reduzir o desvio (σ).</a:t>
+              <a:t>Ganhar tempo médio ajudou mais do que reduzir a variação.</a:t>
             </a:r>
             <a:endParaRPr lang="en-US" sz="1300" dirty="0"/>
           </a:p>
@@ -3924,7 +3924,7 @@
                 <a:ea typeface="Calibri" pitchFamily="34" charset="-122"/>
                 <a:cs typeface="Calibri" pitchFamily="34" charset="-120"/>
               </a:rPr>
-              <a:t>As duas ações combinadas derrubam o risco a menos de um terço.</a:t>
+              <a:t>As duas mudanças juntas derrubam o risco a menos de um terço.</a:t>
             </a:r>
             <a:endParaRPr lang="en-US" sz="1300" dirty="0"/>
           </a:p>
@@ -3948,7 +3948,7 @@
                 <a:ea typeface="Calibri" pitchFamily="34" charset="-122"/>
                 <a:cs typeface="Calibri" pitchFamily="34" charset="-120"/>
               </a:rPr>
-              <a:t>Simular a decisão antes de aplicá-la evita testar hipóteses na operação real.</a:t>
+              <a:t>Simular no computador evita testar a mudança direto na rua.</a:t>
             </a:r>
             <a:endParaRPr lang="en-US" sz="1300" dirty="0"/>
           </a:p>
@@ -4247,7 +4247,7 @@
                 <a:ea typeface="Calibri" pitchFamily="34" charset="-122"/>
                 <a:cs typeface="Calibri" pitchFamily="34" charset="-120"/>
               </a:rPr>
-              <a:t>A taxa geral de 22,5% de atrasos convivia com cenários de 64,7%. Foram a probabilidade condicional e o Teorema de Bayes que mostraram onde o risco se concentra.</a:t>
+              <a:t>Olhando só o total, 22,5% das entregas atrasam. Separando por cenário, o risco chega a 64,7%. A probabilidade mostrou onde estava o problema.</a:t>
             </a:r>
             <a:endParaRPr lang="en-US" sz="1250" dirty="0"/>
           </a:p>
@@ -4372,7 +4372,7 @@
                 <a:ea typeface="Cambria" pitchFamily="34" charset="-122"/>
                 <a:cs typeface="Cambria" pitchFamily="34" charset="-120"/>
               </a:rPr>
-              <a:t>A Normal descreveu bem o tempo</a:t>
+              <a:t>A curva Normal descreveu o tempo</a:t>
             </a:r>
             <a:endParaRPr lang="en-US" sz="1600" dirty="0"/>
           </a:p>
@@ -4414,7 +4414,7 @@
                 <a:ea typeface="Calibri" pitchFamily="34" charset="-122"/>
                 <a:cs typeface="Calibri" pitchFamily="34" charset="-120"/>
               </a:rPr>
-              <a:t>Com μ = 48,9 e σ = 15,4 min, a curva estimou 23,7% de estouro de SLA, contra 22,5% observados, e apontou 75 min como prazo capaz de cobrir 95% das entregas.</a:t>
+              <a:t>Com média de 48,9 e desvio de 15,4 minutos, a curva calculou 23,7% de risco, bem perto dos 22,5% que realmente aconteceram.</a:t>
             </a:r>
             <a:endParaRPr lang="en-US" sz="1250" dirty="0"/>
           </a:p>
@@ -4539,7 +4539,7 @@
                 <a:ea typeface="Cambria" pitchFamily="34" charset="-122"/>
                 <a:cs typeface="Cambria" pitchFamily="34" charset="-120"/>
               </a:rPr>
-              <a:t>Do conceito ao modelo preditivo</a:t>
+              <a:t>Da fórmula ao programa que prevê</a:t>
             </a:r>
             <a:endParaRPr lang="en-US" sz="1600" dirty="0"/>
           </a:p>
@@ -4581,7 +4581,7 @@
                 <a:ea typeface="Calibri" pitchFamily="34" charset="-122"/>
                 <a:cs typeface="Calibri" pitchFamily="34" charset="-120"/>
               </a:rPr>
-              <a:t>Um Naive Bayes Gaussiano escrito do zero, usando apenas Bayes e a densidade normal, atingiu 87,3% de acurácia e 89,1% de precisão em dados nunca vistos.</a:t>
+              <a:t>Usando só as fórmulas dos slides, o modelo acertou 87,3% das entregas de teste, que ele nunca tinha visto antes.</a:t>
             </a:r>
             <a:endParaRPr lang="en-US" sz="1250" dirty="0"/>
           </a:p>
@@ -4706,7 +4706,7 @@
                 <a:ea typeface="Cambria" pitchFamily="34" charset="-122"/>
                 <a:cs typeface="Cambria" pitchFamily="34" charset="-120"/>
               </a:rPr>
-              <a:t>Ganho possível para a operação</a:t>
+              <a:t>O ganho para a empresa</a:t>
             </a:r>
             <a:endParaRPr lang="en-US" sz="1600" dirty="0"/>
           </a:p>
@@ -4748,7 +4748,7 @@
                 <a:ea typeface="Calibri" pitchFamily="34" charset="-122"/>
                 <a:cs typeface="Calibri" pitchFamily="34" charset="-120"/>
               </a:rPr>
-              <a:t>A simulação de Monte Carlo apontou queda do risco de 23,7% para 6,8%, com reflexo em multas de SLA, retrabalho logístico e satisfação do cliente.</a:t>
+              <a:t>Na simulação, o risco cai de 23,7% para 6,8%. Isso significa menos multa por atraso, menos retrabalho e cliente mais satisfeito.</a:t>
             </a:r>
             <a:endParaRPr lang="en-US" sz="1250" dirty="0"/>
           </a:p>
@@ -4787,7 +4787,7 @@
                 <a:ea typeface="Calibri" pitchFamily="34" charset="-122"/>
                 <a:cs typeface="Calibri" pitchFamily="34" charset="-120"/>
               </a:rPr>
-              <a:t>Como continuidade, o mesmo modelo poderia ser treinado com dados reais de telemetria e comparado com regressão logística e gradient boosting.</a:t>
+              <a:t>Como próximo passo, o mesmo modelo poderia ser testado com dados reais da empresa e comparado com outros métodos.</a:t>
             </a:r>
             <a:endParaRPr lang="en-US" sz="1300" dirty="0"/>
           </a:p>
@@ -5650,7 +5650,7 @@
                 <a:ea typeface="Calibri" pitchFamily="34" charset="-122"/>
                 <a:cs typeface="Calibri" pitchFamily="34" charset="-120"/>
               </a:rPr>
-              <a:t>Por que probabilidade é a linguagem da Inteligência Artificial</a:t>
+              <a:t>Qual problema escolhemos e por que ele precisa de probabilidade</a:t>
             </a:r>
             <a:endParaRPr lang="en-US" sz="1400" dirty="0"/>
           </a:p>
@@ -5692,7 +5692,7 @@
                 <a:ea typeface="Calibri" pitchFamily="34" charset="-122"/>
                 <a:cs typeface="Calibri" pitchFamily="34" charset="-120"/>
               </a:rPr>
-              <a:t>Trânsito, clima e distância mudam o tempo de cada entrega, então toda previsão de prazo carrega incerteza. Um modelo preditivo não responde com certezas, e sim com probabilidades. Entender Probabilidade e Distribuição Normal é, portanto, condição para construir e interpretar esse tipo de modelo.</a:t>
+              <a:t>Uma transportadora promete entregar em até 60 minutos. Só que trânsito, chuva e distância mudam esse tempo, então ninguém tem certeza se vai dar. Quando a certeza não existe, a saída é calcular a chance de acontecer. É isso que os dois temas fazem, e é assim que um programa de computador consegue prever.</a:t>
             </a:r>
             <a:endParaRPr lang="en-US" sz="1500" dirty="0"/>
           </a:p>
@@ -6109,7 +6109,7 @@
                 <a:ea typeface="Calibri" pitchFamily="34" charset="-122"/>
                 <a:cs typeface="Calibri" pitchFamily="34" charset="-120"/>
               </a:rPr>
-              <a:t>Modelo probabilístico (Naive Bayes Gaussiano) escrito do zero em Python.</a:t>
+              <a:t>Um programa em Python que calcula a chance de atraso de cada entrega.</a:t>
             </a:r>
             <a:endParaRPr lang="en-US" sz="1300" dirty="0"/>
           </a:p>
@@ -6248,7 +6248,7 @@
                 <a:ea typeface="Calibri" pitchFamily="34" charset="-122"/>
                 <a:cs typeface="Calibri" pitchFamily="34" charset="-120"/>
               </a:rPr>
-              <a:t>Base simulada com números pseudoaleatórios (seed = 42), o que torna o estudo reprodutível.</a:t>
+              <a:t>Mil entregas criadas pelo próprio código, sempre iguais por causa da semente fixa.</a:t>
             </a:r>
             <a:endParaRPr lang="en-US" sz="1300" dirty="0"/>
           </a:p>
@@ -6416,7 +6416,7 @@
                 <a:ea typeface="Calibri" pitchFamily="34" charset="-122"/>
                 <a:cs typeface="Calibri" pitchFamily="34" charset="-120"/>
               </a:rPr>
-              <a:t>4.  A IA consegue prever o atraso antes de ele acontecer?</a:t>
+              <a:t>4.  Dá para prever o atraso antes de ele acontecer?</a:t>
             </a:r>
             <a:endParaRPr lang="en-US" sz="1500" dirty="0"/>
           </a:p>
@@ -6436,7 +6436,7 @@
                 <a:ea typeface="Calibri" pitchFamily="34" charset="-122"/>
                 <a:cs typeface="Calibri" pitchFamily="34" charset="-120"/>
               </a:rPr>
-              <a:t>5.  Que decisão gerencial reduz mais o risco?</a:t>
+              <a:t>5.  Qual mudança na operação reduz mais o risco?</a:t>
             </a:r>
             <a:endParaRPr lang="en-US" sz="1500" dirty="0"/>
           </a:p>
@@ -6605,7 +6605,7 @@
                 <a:ea typeface="Calibri" pitchFamily="34" charset="-122"/>
                 <a:cs typeface="Calibri" pitchFamily="34" charset="-120"/>
               </a:rPr>
-              <a:t>Tema 1: a base matemática do raciocínio sob incerteza</a:t>
+              <a:t>Tema 1: as três fórmulas que usamos no trabalho</a:t>
             </a:r>
             <a:endParaRPr lang="en-US" sz="1400" dirty="0"/>
           </a:p>
@@ -6619,12 +6619,12 @@
         </p:nvSpPr>
         <p:spPr>
           <a:xfrm>
-            <a:off x="566928" y="1572768"/>
-            <a:ext cx="6675120" cy="1371600"/>
+            <a:off x="566928" y="1536192"/>
+            <a:ext cx="6675120" cy="1481328"/>
           </a:xfrm>
           <a:prstGeom prst="roundRect">
             <a:avLst>
-              <a:gd name="adj" fmla="val 5333"/>
+              <a:gd name="adj" fmla="val 4938"/>
             </a:avLst>
           </a:prstGeom>
           <a:solidFill>
@@ -6646,8 +6646,8 @@
         </p:nvSpPr>
         <p:spPr>
           <a:xfrm>
-            <a:off x="841248" y="1700784"/>
-            <a:ext cx="6126480" cy="310896"/>
+            <a:off x="841248" y="1627632"/>
+            <a:ext cx="6126480" cy="292608"/>
           </a:xfrm>
           <a:prstGeom prst="rect">
             <a:avLst/>
@@ -6671,7 +6671,7 @@
                 <a:ea typeface="Cambria" pitchFamily="34" charset="-122"/>
                 <a:cs typeface="Cambria" pitchFamily="34" charset="-120"/>
               </a:rPr>
-              <a:t>Probabilidade clássica</a:t>
+              <a:t>Probabilidade</a:t>
             </a:r>
             <a:endParaRPr lang="en-US" sz="1700" dirty="0"/>
           </a:p>
@@ -6685,24 +6685,24 @@
         </p:nvSpPr>
         <p:spPr>
           <a:xfrm>
-            <a:off x="841248" y="2048256"/>
-            <a:ext cx="6126480" cy="329184"/>
-          </a:xfrm>
-          <a:prstGeom prst="rect">
-            <a:avLst/>
-          </a:prstGeom>
-          <a:noFill/>
-          <a:ln/>
-        </p:spPr>
-        <p:txBody>
-          <a:bodyPr wrap="square" lIns="0" tIns="0" rIns="0" bIns="0" rtlCol="0" anchor="ctr"/>
-          <a:lstStyle/>
-          <a:p>
-            <a:pPr indent="0" marL="0">
-              <a:buNone/>
-            </a:pPr>
-            <a:r>
-              <a:rPr lang="en-US" sz="1500" b="1" dirty="0">
+            <a:off x="841248" y="1956816"/>
+            <a:ext cx="6126480" cy="310896"/>
+          </a:xfrm>
+          <a:prstGeom prst="rect">
+            <a:avLst/>
+          </a:prstGeom>
+          <a:noFill/>
+          <a:ln/>
+        </p:spPr>
+        <p:txBody>
+          <a:bodyPr wrap="square" lIns="0" tIns="0" rIns="0" bIns="0" rtlCol="0" anchor="ctr"/>
+          <a:lstStyle/>
+          <a:p>
+            <a:pPr indent="0" marL="0">
+              <a:buNone/>
+            </a:pPr>
+            <a:r>
+              <a:rPr lang="en-US" sz="1450" b="1" dirty="0">
                 <a:solidFill>
                   <a:srgbClr val="D1495B"/>
                 </a:solidFill>
@@ -6712,7 +6712,7 @@
               </a:rPr>
               <a:t>P(A) = casos favoráveis / casos possíveis</a:t>
             </a:r>
-            <a:endParaRPr lang="en-US" sz="1500" dirty="0"/>
+            <a:endParaRPr lang="en-US" sz="1450" dirty="0"/>
           </a:p>
         </p:txBody>
       </p:sp>
@@ -6724,8 +6724,8 @@
         </p:nvSpPr>
         <p:spPr>
           <a:xfrm>
-            <a:off x="841248" y="2414016"/>
-            <a:ext cx="6126480" cy="365760"/>
+            <a:off x="841248" y="2295144"/>
+            <a:ext cx="6126480" cy="310896"/>
           </a:xfrm>
           <a:prstGeom prst="rect">
             <a:avLst/>
@@ -6749,7 +6749,7 @@
                 <a:ea typeface="Calibri" pitchFamily="34" charset="-122"/>
                 <a:cs typeface="Calibri" pitchFamily="34" charset="-120"/>
               </a:rPr>
-              <a:t>Frequência relativa do evento na base observada.</a:t>
+              <a:t>Quantas vezes o evento aconteceu, dividido pelo total.</a:t>
             </a:r>
             <a:endParaRPr lang="en-US" sz="1250" dirty="0"/>
           </a:p>
@@ -6757,18 +6757,71 @@
       </p:sp>
       <p:sp>
         <p:nvSpPr>
-          <p:cNvPr id="10" name="Shape 8"/>
+          <p:cNvPr id="10" name="Text 8"/>
+          <p:cNvSpPr txBox="1"/>
+          <p:nvPr/>
+        </p:nvSpPr>
+        <p:spPr>
+          <a:xfrm>
+            <a:off x="841248" y="2606040"/>
+            <a:ext cx="6126480" cy="310896"/>
+          </a:xfrm>
+          <a:prstGeom prst="rect">
+            <a:avLst/>
+          </a:prstGeom>
+          <a:noFill/>
+          <a:ln/>
+        </p:spPr>
+        <p:txBody>
+          <a:bodyPr wrap="square" lIns="0" tIns="0" rIns="0" bIns="0" rtlCol="0" anchor="ctr"/>
+          <a:lstStyle/>
+          <a:p>
+            <a:pPr indent="0" marL="0">
+              <a:buNone/>
+            </a:pPr>
+            <a:r>
+              <a:rPr lang="en-US" sz="1250" b="1" dirty="0">
+                <a:solidFill>
+                  <a:srgbClr val="1C7293"/>
+                </a:solidFill>
+                <a:latin typeface="Calibri" pitchFamily="34" charset="0"/>
+                <a:ea typeface="Calibri" pitchFamily="34" charset="-122"/>
+                <a:cs typeface="Calibri" pitchFamily="34" charset="-120"/>
+              </a:rPr>
+              <a:t>Exemplo: </a:t>
+            </a:r>
+            <a:pPr indent="0" marL="0">
+              <a:buNone/>
+            </a:pPr>
+            <a:r>
+              <a:rPr lang="en-US" sz="1250" dirty="0">
+                <a:solidFill>
+                  <a:srgbClr val="1B2A3A"/>
+                </a:solidFill>
+                <a:latin typeface="Calibri" pitchFamily="34" charset="0"/>
+                <a:ea typeface="Calibri" pitchFamily="34" charset="-122"/>
+                <a:cs typeface="Calibri" pitchFamily="34" charset="-120"/>
+              </a:rPr>
+              <a:t>Num dado comum, a chance de sair 6 é 1 em 6, ou seja, 16,7%.</a:t>
+            </a:r>
+            <a:endParaRPr lang="en-US" sz="1250" dirty="0"/>
+          </a:p>
+        </p:txBody>
+      </p:sp>
+      <p:sp>
+        <p:nvSpPr>
+          <p:cNvPr id="11" name="Shape 9"/>
           <p:cNvSpPr/>
           <p:nvPr/>
         </p:nvSpPr>
         <p:spPr>
           <a:xfrm>
-            <a:off x="566928" y="3090672"/>
-            <a:ext cx="6675120" cy="1371600"/>
+            <a:off x="566928" y="3108960"/>
+            <a:ext cx="6675120" cy="1481328"/>
           </a:xfrm>
           <a:prstGeom prst="roundRect">
             <a:avLst>
-              <a:gd name="adj" fmla="val 5333"/>
+              <a:gd name="adj" fmla="val 4938"/>
             </a:avLst>
           </a:prstGeom>
           <a:solidFill>
@@ -6784,14 +6837,14 @@
       </p:sp>
       <p:sp>
         <p:nvSpPr>
-          <p:cNvPr id="11" name="Text 9"/>
-          <p:cNvSpPr txBox="1"/>
-          <p:nvPr/>
-        </p:nvSpPr>
-        <p:spPr>
-          <a:xfrm>
-            <a:off x="841248" y="3218688"/>
-            <a:ext cx="6126480" cy="310896"/>
+          <p:cNvPr id="12" name="Text 10"/>
+          <p:cNvSpPr txBox="1"/>
+          <p:nvPr/>
+        </p:nvSpPr>
+        <p:spPr>
+          <a:xfrm>
+            <a:off x="841248" y="3200400"/>
+            <a:ext cx="6126480" cy="292608"/>
           </a:xfrm>
           <a:prstGeom prst="rect">
             <a:avLst/>
@@ -6823,30 +6876,30 @@
       </p:sp>
       <p:sp>
         <p:nvSpPr>
-          <p:cNvPr id="12" name="Text 10"/>
-          <p:cNvSpPr txBox="1"/>
-          <p:nvPr/>
-        </p:nvSpPr>
-        <p:spPr>
-          <a:xfrm>
-            <a:off x="841248" y="3566160"/>
-            <a:ext cx="6126480" cy="329184"/>
-          </a:xfrm>
-          <a:prstGeom prst="rect">
-            <a:avLst/>
-          </a:prstGeom>
-          <a:noFill/>
-          <a:ln/>
-        </p:spPr>
-        <p:txBody>
-          <a:bodyPr wrap="square" lIns="0" tIns="0" rIns="0" bIns="0" rtlCol="0" anchor="ctr"/>
-          <a:lstStyle/>
-          <a:p>
-            <a:pPr indent="0" marL="0">
-              <a:buNone/>
-            </a:pPr>
-            <a:r>
-              <a:rPr lang="en-US" sz="1500" b="1" dirty="0">
+          <p:cNvPr id="13" name="Text 11"/>
+          <p:cNvSpPr txBox="1"/>
+          <p:nvPr/>
+        </p:nvSpPr>
+        <p:spPr>
+          <a:xfrm>
+            <a:off x="841248" y="3529584"/>
+            <a:ext cx="6126480" cy="310896"/>
+          </a:xfrm>
+          <a:prstGeom prst="rect">
+            <a:avLst/>
+          </a:prstGeom>
+          <a:noFill/>
+          <a:ln/>
+        </p:spPr>
+        <p:txBody>
+          <a:bodyPr wrap="square" lIns="0" tIns="0" rIns="0" bIns="0" rtlCol="0" anchor="ctr"/>
+          <a:lstStyle/>
+          <a:p>
+            <a:pPr indent="0" marL="0">
+              <a:buNone/>
+            </a:pPr>
+            <a:r>
+              <a:rPr lang="en-US" sz="1450" b="1" dirty="0">
                 <a:solidFill>
                   <a:srgbClr val="D1495B"/>
                 </a:solidFill>
@@ -6854,22 +6907,22 @@
                 <a:ea typeface="Courier New" pitchFamily="34" charset="-122"/>
                 <a:cs typeface="Courier New" pitchFamily="34" charset="-120"/>
               </a:rPr>
-              <a:t>P(A|B) = P(A ∩ B) / P(B)</a:t>
-            </a:r>
-            <a:endParaRPr lang="en-US" sz="1500" dirty="0"/>
-          </a:p>
-        </p:txBody>
-      </p:sp>
-      <p:sp>
-        <p:nvSpPr>
-          <p:cNvPr id="13" name="Text 11"/>
-          <p:cNvSpPr txBox="1"/>
-          <p:nvPr/>
-        </p:nvSpPr>
-        <p:spPr>
-          <a:xfrm>
-            <a:off x="841248" y="3931920"/>
-            <a:ext cx="6126480" cy="365760"/>
+              <a:t>P(A|B) = P(A e B) / P(B)</a:t>
+            </a:r>
+            <a:endParaRPr lang="en-US" sz="1450" dirty="0"/>
+          </a:p>
+        </p:txBody>
+      </p:sp>
+      <p:sp>
+        <p:nvSpPr>
+          <p:cNvPr id="14" name="Text 12"/>
+          <p:cNvSpPr txBox="1"/>
+          <p:nvPr/>
+        </p:nvSpPr>
+        <p:spPr>
+          <a:xfrm>
+            <a:off x="841248" y="3867912"/>
+            <a:ext cx="6126480" cy="310896"/>
           </a:xfrm>
           <a:prstGeom prst="rect">
             <a:avLst/>
@@ -6893,7 +6946,7 @@
                 <a:ea typeface="Calibri" pitchFamily="34" charset="-122"/>
                 <a:cs typeface="Calibri" pitchFamily="34" charset="-120"/>
               </a:rPr>
-              <a:t>Atualiza a chance de A quando já se sabe que B ocorreu.</a:t>
+              <a:t>A chance de algo acontecer quando já sabemos que outra coisa aconteceu.</a:t>
             </a:r>
             <a:endParaRPr lang="en-US" sz="1250" dirty="0"/>
           </a:p>
@@ -6901,18 +6954,71 @@
       </p:sp>
       <p:sp>
         <p:nvSpPr>
-          <p:cNvPr id="14" name="Shape 12"/>
+          <p:cNvPr id="15" name="Text 13"/>
+          <p:cNvSpPr txBox="1"/>
+          <p:nvPr/>
+        </p:nvSpPr>
+        <p:spPr>
+          <a:xfrm>
+            <a:off x="841248" y="4178808"/>
+            <a:ext cx="6126480" cy="310896"/>
+          </a:xfrm>
+          <a:prstGeom prst="rect">
+            <a:avLst/>
+          </a:prstGeom>
+          <a:noFill/>
+          <a:ln/>
+        </p:spPr>
+        <p:txBody>
+          <a:bodyPr wrap="square" lIns="0" tIns="0" rIns="0" bIns="0" rtlCol="0" anchor="ctr"/>
+          <a:lstStyle/>
+          <a:p>
+            <a:pPr indent="0" marL="0">
+              <a:buNone/>
+            </a:pPr>
+            <a:r>
+              <a:rPr lang="en-US" sz="1250" b="1" dirty="0">
+                <a:solidFill>
+                  <a:srgbClr val="1C7293"/>
+                </a:solidFill>
+                <a:latin typeface="Calibri" pitchFamily="34" charset="0"/>
+                <a:ea typeface="Calibri" pitchFamily="34" charset="-122"/>
+                <a:cs typeface="Calibri" pitchFamily="34" charset="-120"/>
+              </a:rPr>
+              <a:t>Exemplo: </a:t>
+            </a:r>
+            <a:pPr indent="0" marL="0">
+              <a:buNone/>
+            </a:pPr>
+            <a:r>
+              <a:rPr lang="en-US" sz="1250" dirty="0">
+                <a:solidFill>
+                  <a:srgbClr val="1B2A3A"/>
+                </a:solidFill>
+                <a:latin typeface="Calibri" pitchFamily="34" charset="0"/>
+                <a:ea typeface="Calibri" pitchFamily="34" charset="-122"/>
+                <a:cs typeface="Calibri" pitchFamily="34" charset="-120"/>
+              </a:rPr>
+              <a:t>Se alguém já disse que saiu número par, a chance de ser 6 sobe para 1 em 3.</a:t>
+            </a:r>
+            <a:endParaRPr lang="en-US" sz="1250" dirty="0"/>
+          </a:p>
+        </p:txBody>
+      </p:sp>
+      <p:sp>
+        <p:nvSpPr>
+          <p:cNvPr id="16" name="Shape 14"/>
           <p:cNvSpPr/>
           <p:nvPr/>
         </p:nvSpPr>
         <p:spPr>
           <a:xfrm>
-            <a:off x="566928" y="4608576"/>
-            <a:ext cx="6675120" cy="1371600"/>
+            <a:off x="566928" y="4681728"/>
+            <a:ext cx="6675120" cy="1481328"/>
           </a:xfrm>
           <a:prstGeom prst="roundRect">
             <a:avLst>
-              <a:gd name="adj" fmla="val 5333"/>
+              <a:gd name="adj" fmla="val 4938"/>
             </a:avLst>
           </a:prstGeom>
           <a:solidFill>
@@ -6928,14 +7034,14 @@
       </p:sp>
       <p:sp>
         <p:nvSpPr>
-          <p:cNvPr id="15" name="Text 13"/>
-          <p:cNvSpPr txBox="1"/>
-          <p:nvPr/>
-        </p:nvSpPr>
-        <p:spPr>
-          <a:xfrm>
-            <a:off x="841248" y="4736592"/>
-            <a:ext cx="6126480" cy="310896"/>
+          <p:cNvPr id="17" name="Text 15"/>
+          <p:cNvSpPr txBox="1"/>
+          <p:nvPr/>
+        </p:nvSpPr>
+        <p:spPr>
+          <a:xfrm>
+            <a:off x="841248" y="4773168"/>
+            <a:ext cx="6126480" cy="292608"/>
           </a:xfrm>
           <a:prstGeom prst="rect">
             <a:avLst/>
@@ -6967,30 +7073,30 @@
       </p:sp>
       <p:sp>
         <p:nvSpPr>
-          <p:cNvPr id="16" name="Text 14"/>
-          <p:cNvSpPr txBox="1"/>
-          <p:nvPr/>
-        </p:nvSpPr>
-        <p:spPr>
-          <a:xfrm>
-            <a:off x="841248" y="5084064"/>
-            <a:ext cx="6126480" cy="329184"/>
-          </a:xfrm>
-          <a:prstGeom prst="rect">
-            <a:avLst/>
-          </a:prstGeom>
-          <a:noFill/>
-          <a:ln/>
-        </p:spPr>
-        <p:txBody>
-          <a:bodyPr wrap="square" lIns="0" tIns="0" rIns="0" bIns="0" rtlCol="0" anchor="ctr"/>
-          <a:lstStyle/>
-          <a:p>
-            <a:pPr indent="0" marL="0">
-              <a:buNone/>
-            </a:pPr>
-            <a:r>
-              <a:rPr lang="en-US" sz="1500" b="1" dirty="0">
+          <p:cNvPr id="18" name="Text 16"/>
+          <p:cNvSpPr txBox="1"/>
+          <p:nvPr/>
+        </p:nvSpPr>
+        <p:spPr>
+          <a:xfrm>
+            <a:off x="841248" y="5102352"/>
+            <a:ext cx="6126480" cy="310896"/>
+          </a:xfrm>
+          <a:prstGeom prst="rect">
+            <a:avLst/>
+          </a:prstGeom>
+          <a:noFill/>
+          <a:ln/>
+        </p:spPr>
+        <p:txBody>
+          <a:bodyPr wrap="square" lIns="0" tIns="0" rIns="0" bIns="0" rtlCol="0" anchor="ctr"/>
+          <a:lstStyle/>
+          <a:p>
+            <a:pPr indent="0" marL="0">
+              <a:buNone/>
+            </a:pPr>
+            <a:r>
+              <a:rPr lang="en-US" sz="1450" b="1" dirty="0">
                 <a:solidFill>
                   <a:srgbClr val="D1495B"/>
                 </a:solidFill>
@@ -6998,22 +7104,22 @@
                 <a:ea typeface="Courier New" pitchFamily="34" charset="-122"/>
                 <a:cs typeface="Courier New" pitchFamily="34" charset="-120"/>
               </a:rPr>
-              <a:t>P(B|A) = P(A|B) · P(B) / P(A)</a:t>
-            </a:r>
-            <a:endParaRPr lang="en-US" sz="1500" dirty="0"/>
-          </a:p>
-        </p:txBody>
-      </p:sp>
-      <p:sp>
-        <p:nvSpPr>
-          <p:cNvPr id="17" name="Text 15"/>
-          <p:cNvSpPr txBox="1"/>
-          <p:nvPr/>
-        </p:nvSpPr>
-        <p:spPr>
-          <a:xfrm>
-            <a:off x="841248" y="5449824"/>
-            <a:ext cx="6126480" cy="365760"/>
+              <a:t>P(B|A) = P(A|B) x P(B) / P(A)</a:t>
+            </a:r>
+            <a:endParaRPr lang="en-US" sz="1450" dirty="0"/>
+          </a:p>
+        </p:txBody>
+      </p:sp>
+      <p:sp>
+        <p:nvSpPr>
+          <p:cNvPr id="19" name="Text 17"/>
+          <p:cNvSpPr txBox="1"/>
+          <p:nvPr/>
+        </p:nvSpPr>
+        <p:spPr>
+          <a:xfrm>
+            <a:off x="841248" y="5440680"/>
+            <a:ext cx="6126480" cy="310896"/>
           </a:xfrm>
           <a:prstGeom prst="rect">
             <a:avLst/>
@@ -7037,7 +7143,7 @@
                 <a:ea typeface="Calibri" pitchFamily="34" charset="-122"/>
                 <a:cs typeface="Calibri" pitchFamily="34" charset="-120"/>
               </a:rPr>
-              <a:t>Inverte a condicional e sustenta os classificadores probabilísticos.</a:t>
+              <a:t>Vira a pergunta do avesso: a partir do resultado, descobre a causa provável.</a:t>
             </a:r>
             <a:endParaRPr lang="en-US" sz="1250" dirty="0"/>
           </a:p>
@@ -7045,7 +7151,60 @@
       </p:sp>
       <p:sp>
         <p:nvSpPr>
-          <p:cNvPr id="18" name="Shape 16"/>
+          <p:cNvPr id="20" name="Text 18"/>
+          <p:cNvSpPr txBox="1"/>
+          <p:nvPr/>
+        </p:nvSpPr>
+        <p:spPr>
+          <a:xfrm>
+            <a:off x="841248" y="5751576"/>
+            <a:ext cx="6126480" cy="310896"/>
+          </a:xfrm>
+          <a:prstGeom prst="rect">
+            <a:avLst/>
+          </a:prstGeom>
+          <a:noFill/>
+          <a:ln/>
+        </p:spPr>
+        <p:txBody>
+          <a:bodyPr wrap="square" lIns="0" tIns="0" rIns="0" bIns="0" rtlCol="0" anchor="ctr"/>
+          <a:lstStyle/>
+          <a:p>
+            <a:pPr indent="0" marL="0">
+              <a:buNone/>
+            </a:pPr>
+            <a:r>
+              <a:rPr lang="en-US" sz="1250" b="1" dirty="0">
+                <a:solidFill>
+                  <a:srgbClr val="1C7293"/>
+                </a:solidFill>
+                <a:latin typeface="Calibri" pitchFamily="34" charset="0"/>
+                <a:ea typeface="Calibri" pitchFamily="34" charset="-122"/>
+                <a:cs typeface="Calibri" pitchFamily="34" charset="-120"/>
+              </a:rPr>
+              <a:t>Exemplo: </a:t>
+            </a:r>
+            <a:pPr indent="0" marL="0">
+              <a:buNone/>
+            </a:pPr>
+            <a:r>
+              <a:rPr lang="en-US" sz="1250" dirty="0">
+                <a:solidFill>
+                  <a:srgbClr val="1B2A3A"/>
+                </a:solidFill>
+                <a:latin typeface="Calibri" pitchFamily="34" charset="0"/>
+                <a:ea typeface="Calibri" pitchFamily="34" charset="-122"/>
+                <a:cs typeface="Calibri" pitchFamily="34" charset="-120"/>
+              </a:rPr>
+              <a:t>O médico vê a febre e calcula qual doença é a causa mais provável.</a:t>
+            </a:r>
+            <a:endParaRPr lang="en-US" sz="1250" dirty="0"/>
+          </a:p>
+        </p:txBody>
+      </p:sp>
+      <p:sp>
+        <p:nvSpPr>
+          <p:cNvPr id="21" name="Shape 19"/>
           <p:cNvSpPr/>
           <p:nvPr/>
         </p:nvSpPr>
@@ -7072,7 +7231,7 @@
       </p:sp>
       <p:sp>
         <p:nvSpPr>
-          <p:cNvPr id="19" name="Text 17"/>
+          <p:cNvPr id="22" name="Text 20"/>
           <p:cNvSpPr txBox="1"/>
           <p:nvPr/>
         </p:nvSpPr>
@@ -7103,7 +7262,7 @@
                 <a:ea typeface="Calibri" pitchFamily="34" charset="-122"/>
                 <a:cs typeface="Calibri" pitchFamily="34" charset="-120"/>
               </a:rPr>
-              <a:t>AXIOMAS DE KOLMOGOROV</a:t>
+              <a:t>REGRAS BÁSICAS</a:t>
             </a:r>
             <a:endParaRPr lang="en-US" sz="1050" dirty="0"/>
           </a:p>
@@ -7111,7 +7270,7 @@
       </p:sp>
       <p:sp>
         <p:nvSpPr>
-          <p:cNvPr id="20" name="Text 18"/>
+          <p:cNvPr id="23" name="Text 21"/>
           <p:cNvSpPr txBox="1"/>
           <p:nvPr/>
         </p:nvSpPr>
@@ -7145,7 +7304,7 @@
                 <a:ea typeface="Calibri" pitchFamily="34" charset="-122"/>
                 <a:cs typeface="Calibri" pitchFamily="34" charset="-120"/>
               </a:rPr>
-              <a:t>0 ≤ P(A) ≤ 1</a:t>
+              <a:t>Toda chance fica entre 0 e 1 (0% e 100%)</a:t>
             </a:r>
             <a:endParaRPr lang="en-US" sz="1350" dirty="0"/>
           </a:p>
@@ -7165,7 +7324,7 @@
                 <a:ea typeface="Calibri" pitchFamily="34" charset="-122"/>
                 <a:cs typeface="Calibri" pitchFamily="34" charset="-120"/>
               </a:rPr>
-              <a:t>P(espaço amostral) = 1</a:t>
+              <a:t>A soma de todas as possibilidades dá 1</a:t>
             </a:r>
             <a:endParaRPr lang="en-US" sz="1350" dirty="0"/>
           </a:p>
@@ -7185,7 +7344,7 @@
                 <a:ea typeface="Calibri" pitchFamily="34" charset="-122"/>
                 <a:cs typeface="Calibri" pitchFamily="34" charset="-120"/>
               </a:rPr>
-              <a:t>A e B disjuntos ⇒ P(A ∪ B) = P(A) + P(B)</a:t>
+              <a:t>Se A e B não acontecem juntos, somam-se as chances</a:t>
             </a:r>
             <a:endParaRPr lang="en-US" sz="1350" dirty="0"/>
           </a:p>
@@ -7193,7 +7352,7 @@
       </p:sp>
       <p:sp>
         <p:nvSpPr>
-          <p:cNvPr id="21" name="Text 19"/>
+          <p:cNvPr id="24" name="Text 22"/>
           <p:cNvSpPr txBox="1"/>
           <p:nvPr/>
         </p:nvSpPr>
@@ -7224,7 +7383,7 @@
                 <a:ea typeface="Cambria" pitchFamily="34" charset="-122"/>
                 <a:cs typeface="Cambria" pitchFamily="34" charset="-120"/>
               </a:rPr>
-              <a:t>Onde isso aparece na IA</a:t>
+              <a:t>Onde isso é usado</a:t>
             </a:r>
             <a:endParaRPr lang="en-US" sz="1700" dirty="0"/>
           </a:p>
@@ -7232,7 +7391,7 @@
       </p:sp>
       <p:sp>
         <p:nvSpPr>
-          <p:cNvPr id="22" name="Text 20"/>
+          <p:cNvPr id="25" name="Text 23"/>
           <p:cNvSpPr txBox="1"/>
           <p:nvPr/>
         </p:nvSpPr>
@@ -7270,7 +7429,7 @@
                 <a:ea typeface="Calibri" pitchFamily="34" charset="-122"/>
                 <a:cs typeface="Calibri" pitchFamily="34" charset="-120"/>
               </a:rPr>
-              <a:t>Classificadores como Naive Bayes e regressão logística</a:t>
+              <a:t>Aplicativo que avisa se vai chover hoje</a:t>
             </a:r>
             <a:endParaRPr lang="en-US" sz="1350" dirty="0"/>
           </a:p>
@@ -7294,7 +7453,7 @@
                 <a:ea typeface="Calibri" pitchFamily="34" charset="-122"/>
                 <a:cs typeface="Calibri" pitchFamily="34" charset="-120"/>
               </a:rPr>
-              <a:t>Saída de redes neurais pela função softmax</a:t>
+              <a:t>Filtro que separa e-mail de spam</a:t>
             </a:r>
             <a:endParaRPr lang="en-US" sz="1350" dirty="0"/>
           </a:p>
@@ -7318,7 +7477,7 @@
                 <a:ea typeface="Calibri" pitchFamily="34" charset="-122"/>
                 <a:cs typeface="Calibri" pitchFamily="34" charset="-120"/>
               </a:rPr>
-              <a:t>Filtros de spam e sistemas de recomendação</a:t>
+              <a:t>Banco que avalia risco de um empréstimo</a:t>
             </a:r>
             <a:endParaRPr lang="en-US" sz="1350" dirty="0"/>
           </a:p>
@@ -7342,7 +7501,7 @@
                 <a:ea typeface="Calibri" pitchFamily="34" charset="-122"/>
                 <a:cs typeface="Calibri" pitchFamily="34" charset="-120"/>
               </a:rPr>
-              <a:t>Cálculo de risco e precificação de seguros</a:t>
+              <a:t>Netflix e YouTube sugerindo o próximo vídeo</a:t>
             </a:r>
             <a:endParaRPr lang="en-US" sz="1350" dirty="0"/>
           </a:p>
@@ -7511,7 +7670,7 @@
                 <a:ea typeface="Calibri" pitchFamily="34" charset="-122"/>
                 <a:cs typeface="Calibri" pitchFamily="34" charset="-120"/>
               </a:rPr>
-              <a:t>Simulação controlada de 1.000 entregas urbanas em Python</a:t>
+              <a:t>Mil entregas criadas pelo próprio programa</a:t>
             </a:r>
             <a:endParaRPr lang="en-US" sz="1400" dirty="0"/>
           </a:p>
@@ -7553,7 +7712,7 @@
                 <a:ea typeface="Calibri" pitchFamily="34" charset="-122"/>
                 <a:cs typeface="Calibri" pitchFamily="34" charset="-120"/>
               </a:rPr>
-              <a:t>O computador não gera acaso verdadeiro. Um algoritmo determinístico parte de uma semente (seed) e produz uma sequência com propriedades estatísticas de aleatoriedade. Como a semente está fixa, qualquer execução devolve os mesmos números.</a:t>
+              <a:t>O computador não sorteia de verdade. Ele segue uma conta que parte de um número inicial, a semente, e devolve valores que parecem sorteados. Como a semente está fixa em 42, rodar o código hoje ou amanhã dá exatamente o mesmo resultado.</a:t>
             </a:r>
             <a:endParaRPr lang="en-US" sz="1400" dirty="0"/>
           </a:p>
@@ -7778,7 +7937,7 @@
                 <a:ea typeface="Cambria" pitchFamily="34" charset="-122"/>
                 <a:cs typeface="Cambria" pitchFamily="34" charset="-120"/>
               </a:rPr>
-              <a:t>Cada variável tem uma distribuição por trás</a:t>
+              <a:t>Parece sorteio, mas é repetível</a:t>
             </a:r>
             <a:endParaRPr lang="en-US" sz="1500" dirty="0"/>
           </a:p>
@@ -7817,7 +7976,7 @@
                 <a:ea typeface="Calibri" pitchFamily="34" charset="-122"/>
                 <a:cs typeface="Calibri" pitchFamily="34" charset="-120"/>
               </a:rPr>
-              <a:t>Distância ~ Normal(12; 4), Chuva ~ Bernoulli(0,30), Pico ~ Bernoulli(0,40), Erro ~ Normal(0; 7)</a:t>
+              <a:t>É como um baralho embaralhado sempre da mesma forma: o resultado parece sorteado, mas qualquer pessoa consegue repetir o mesmo embaralhamento e conferir nossas contas.</a:t>
             </a:r>
             <a:endParaRPr lang="en-US" sz="1250" dirty="0"/>
           </a:p>
@@ -9899,7 +10058,7 @@
                 <a:ea typeface="Calibri" pitchFamily="34" charset="-122"/>
                 <a:cs typeface="Calibri" pitchFamily="34" charset="-120"/>
               </a:rPr>
-              <a:t>A coluna alvo segue uma regra simples: atraso = 1 quando o tempo simulado ultrapassa o SLA de 60 minutos.</a:t>
+              <a:t>A última coluna é o que queremos prever: vale 1 quando o tempo passa de 60 minutos.</a:t>
             </a:r>
             <a:endParaRPr lang="en-US" sz="1250" dirty="0"/>
           </a:p>
@@ -10068,7 +10227,7 @@
                 <a:ea typeface="Calibri" pitchFamily="34" charset="-122"/>
                 <a:cs typeface="Calibri" pitchFamily="34" charset="-120"/>
               </a:rPr>
-              <a:t>Executando o código: como cada fator muda o risco de atraso</a:t>
+              <a:t>Rodando o código: o risco muda muito de um cenário para outro</a:t>
             </a:r>
             <a:endParaRPr lang="en-US" sz="1400" dirty="0"/>
           </a:p>
@@ -10731,7 +10890,7 @@
                 <a:ea typeface="Calibri" pitchFamily="34" charset="-122"/>
                 <a:cs typeface="Calibri" pitchFamily="34" charset="-120"/>
               </a:rPr>
-              <a:t>Com chuva, a chance de estourar o prazo quase triplica.</a:t>
+              <a:t>Com chuva, a chance de perder o prazo quase triplica.</a:t>
             </a:r>
             <a:endParaRPr lang="en-US" sz="1250" dirty="0"/>
           </a:p>
@@ -10861,7 +11020,7 @@
                 <a:ea typeface="Cambria" pitchFamily="34" charset="-122"/>
                 <a:cs typeface="Cambria" pitchFamily="34" charset="-120"/>
               </a:rPr>
-              <a:t>Teorema de Bayes: invertendo a pergunta</a:t>
+              <a:t>Teorema de Bayes na prática</a:t>
             </a:r>
             <a:endParaRPr lang="en-US" sz="3000" dirty="0"/>
           </a:p>
@@ -11032,7 +11191,7 @@
                 <a:ea typeface="Cambria" pitchFamily="34" charset="-122"/>
                 <a:cs typeface="Cambria" pitchFamily="34" charset="-120"/>
               </a:rPr>
-              <a:t>Verossimilhança</a:t>
+              <a:t>O que já sabemos</a:t>
             </a:r>
             <a:endParaRPr lang="en-US" sz="1500" dirty="0"/>
           </a:p>
@@ -11110,7 +11269,7 @@
                 <a:ea typeface="Calibri" pitchFamily="34" charset="-122"/>
                 <a:cs typeface="Calibri" pitchFamily="34" charset="-120"/>
               </a:rPr>
-              <a:t>O que a base mostra sobre o efeito da chuva.</a:t>
+              <a:t>Das entregas com chuva, 41% atrasaram.</a:t>
             </a:r>
             <a:endParaRPr lang="en-US" sz="1200" dirty="0"/>
           </a:p>
@@ -11176,7 +11335,7 @@
                 <a:ea typeface="Cambria" pitchFamily="34" charset="-122"/>
                 <a:cs typeface="Cambria" pitchFamily="34" charset="-120"/>
               </a:rPr>
-              <a:t>Priori</a:t>
+              <a:t>Chance de chover</a:t>
             </a:r>
             <a:endParaRPr lang="en-US" sz="1500" dirty="0"/>
           </a:p>
@@ -11254,7 +11413,7 @@
                 <a:ea typeface="Calibri" pitchFamily="34" charset="-122"/>
                 <a:cs typeface="Calibri" pitchFamily="34" charset="-120"/>
               </a:rPr>
-              <a:t>Chance de chuva antes de observar a entrega.</a:t>
+              <a:t>Choveu em 30,7% das entregas da base.</a:t>
             </a:r>
             <a:endParaRPr lang="en-US" sz="1200" dirty="0"/>
           </a:p>
@@ -11320,7 +11479,7 @@
                 <a:ea typeface="Cambria" pitchFamily="34" charset="-122"/>
                 <a:cs typeface="Cambria" pitchFamily="34" charset="-120"/>
               </a:rPr>
-              <a:t>Evidência</a:t>
+              <a:t>Chance de atrasar</a:t>
             </a:r>
             <a:endParaRPr lang="en-US" sz="1500" dirty="0"/>
           </a:p>
@@ -11398,7 +11557,7 @@
                 <a:ea typeface="Calibri" pitchFamily="34" charset="-122"/>
                 <a:cs typeface="Calibri" pitchFamily="34" charset="-120"/>
               </a:rPr>
-              <a:t>Normaliza o resultado para virar probabilidade.</a:t>
+              <a:t>22,5% de todas as entregas atrasaram.</a:t>
             </a:r>
             <a:endParaRPr lang="en-US" sz="1200" dirty="0"/>
           </a:p>
@@ -11464,7 +11623,7 @@
                 <a:ea typeface="Cambria" pitchFamily="34" charset="-122"/>
                 <a:cs typeface="Cambria" pitchFamily="34" charset="-120"/>
               </a:rPr>
-              <a:t>Posteriori</a:t>
+              <a:t>Resposta</a:t>
             </a:r>
             <a:endParaRPr lang="en-US" sz="1500" dirty="0"/>
           </a:p>
@@ -11542,7 +11701,7 @@
                 <a:ea typeface="Calibri" pitchFamily="34" charset="-122"/>
                 <a:cs typeface="Calibri" pitchFamily="34" charset="-120"/>
               </a:rPr>
-              <a:t>56% das entregas atrasadas ocorreram sob chuva.</a:t>
+              <a:t>Das entregas que atrasaram, 56% foram em dia de chuva.</a:t>
             </a:r>
             <a:endParaRPr lang="en-US" sz="1200" dirty="0"/>
           </a:p>
@@ -11584,7 +11743,7 @@
                 <a:ea typeface="Calibri" pitchFamily="34" charset="-122"/>
                 <a:cs typeface="Calibri" pitchFamily="34" charset="-120"/>
               </a:rPr>
-              <a:t>Validação no código: </a:t>
+              <a:t>Conferindo no código: </a:t>
             </a:r>
             <a:pPr indent="0" marL="0">
               <a:lnSpc>
@@ -11601,7 +11760,7 @@
                 <a:ea typeface="Calibri" pitchFamily="34" charset="-122"/>
                 <a:cs typeface="Calibri" pitchFamily="34" charset="-120"/>
               </a:rPr>
-              <a:t>o valor calculado pela fórmula (0,560) coincide com a frequência observada na base, df.loc[df['atraso']==1, 'chuva'].mean() = 0,560.</a:t>
+              <a:t>contamos na base quantas entregas atrasadas tiveram chuva e deu 0,560, exatamente o mesmo valor da fórmula.</a:t>
             </a:r>
             <a:endParaRPr lang="en-US" sz="1400" dirty="0"/>
           </a:p>
@@ -11731,7 +11890,7 @@
                 <a:ea typeface="Cambria" pitchFamily="34" charset="-122"/>
                 <a:cs typeface="Cambria" pitchFamily="34" charset="-120"/>
               </a:rPr>
-              <a:t>Distribuição Normal: modelando o tempo</a:t>
+              <a:t>Distribuição Normal do tempo de entrega</a:t>
             </a:r>
             <a:endParaRPr lang="en-US" sz="3000" dirty="0"/>
           </a:p>
@@ -11770,7 +11929,7 @@
                 <a:ea typeface="Calibri" pitchFamily="34" charset="-122"/>
                 <a:cs typeface="Calibri" pitchFamily="34" charset="-120"/>
               </a:rPr>
-              <a:t>Tema 2: a curva que descreve grandezas contínuas somadas</a:t>
+              <a:t>Tema 2: a curva em formato de sino</a:t>
             </a:r>
             <a:endParaRPr lang="en-US" sz="1400" dirty="0"/>
           </a:p>
@@ -11833,7 +11992,7 @@
                 <a:ea typeface="Calibri" pitchFamily="34" charset="-122"/>
                 <a:cs typeface="Calibri" pitchFamily="34" charset="-120"/>
               </a:rPr>
-              <a:t>Com média e desvio conhecidos, a curva responde qualquer pergunta de prazo, inclusive sobre valores que a base não observou.</a:t>
+              <a:t>A altura das pessoas e as notas de uma prova se comportam assim: a maioria fica perto da média e poucos ficam nos extremos. Com o tempo de entrega acontece o mesmo.</a:t>
             </a:r>
             <a:endParaRPr lang="en-US" sz="1250" dirty="0"/>
           </a:p>
@@ -12121,7 +12280,7 @@
                 <a:ea typeface="Cambria" pitchFamily="34" charset="-122"/>
                 <a:cs typeface="Cambria" pitchFamily="34" charset="-120"/>
               </a:rPr>
-              <a:t>Padronização (escore z)</a:t>
+              <a:t>Chance de passar dos 60 minutos</a:t>
             </a:r>
             <a:endParaRPr lang="en-US" sz="1600" dirty="0"/>
           </a:p>
@@ -12260,7 +12419,7 @@
                 <a:ea typeface="Calibri" pitchFamily="34" charset="-122"/>
                 <a:cs typeface="Calibri" pitchFamily="34" charset="-120"/>
               </a:rPr>
-              <a:t>Percentil 95: prometer 75 min cumpriria o prazo em 95% das entregas.</a:t>
+              <a:t>A curva também mostra que prometer 75 minutos daria conta de 95% das entregas.</a:t>
             </a:r>
             <a:endParaRPr lang="en-US" sz="1250" dirty="0"/>
           </a:p>
@@ -12390,7 +12549,7 @@
                 <a:ea typeface="Cambria" pitchFamily="34" charset="-122"/>
                 <a:cs typeface="Cambria" pitchFamily="34" charset="-120"/>
               </a:rPr>
-              <a:t>Por que a Normal aparece tanto?</a:t>
+              <a:t>Por que essa curva aparece tanto?</a:t>
             </a:r>
             <a:endParaRPr lang="en-US" sz="3000" dirty="0"/>
           </a:p>
@@ -12429,7 +12588,7 @@
                 <a:ea typeface="Calibri" pitchFamily="34" charset="-122"/>
                 <a:cs typeface="Calibri" pitchFamily="34" charset="-120"/>
               </a:rPr>
-              <a:t>Teste de normalidade, regra empírica e Teorema Central do Limite</a:t>
+              <a:t>Conferindo se os dados realmente seguem a curva Normal</a:t>
             </a:r>
             <a:endParaRPr lang="en-US" sz="1400" dirty="0"/>
           </a:p>
@@ -12495,7 +12654,7 @@
                 <a:ea typeface="Calibri" pitchFamily="34" charset="-122"/>
                 <a:cs typeface="Calibri" pitchFamily="34" charset="-120"/>
               </a:rPr>
-              <a:t>Mesmo partindo de uma população fortemente assimétrica (exponencial), a distribuição das médias amostrais converge para a Normal conforme n cresce. Essa é a razão de a curva aparecer em tantos métodos estatísticos.</a:t>
+              <a:t>No primeiro gráfico os dados são bem tortos, nada parecido com um sino. Mas quando tiramos médias de grupos de 5 e depois de 50, o desenho vai virando o sino da Normal. Por isso essa curva aparece em quase tudo.</a:t>
             </a:r>
             <a:endParaRPr lang="en-US" sz="1400" dirty="0"/>
           </a:p>
@@ -13533,7 +13692,7 @@
                 <a:ea typeface="Calibri" pitchFamily="34" charset="-122"/>
                 <a:cs typeface="Calibri" pitchFamily="34" charset="-120"/>
               </a:rPr>
-              <a:t>Como p &gt; 0,05, não rejeitamos H₀: os dados são compatíveis com a Normal.</a:t>
+              <a:t>O valor de p ficou acima de 0,05, então os dados combinam com a Normal.</a:t>
             </a:r>
             <a:endParaRPr lang="en-US" sz="1150" dirty="0"/>
           </a:p>
@@ -13599,7 +13758,7 @@
                 <a:ea typeface="Calibri" pitchFamily="34" charset="-122"/>
                 <a:cs typeface="Calibri" pitchFamily="34" charset="-120"/>
               </a:rPr>
-              <a:t>ONDE A NORMAL É USADA</a:t>
+              <a:t>ONDE A CURVA NORMAL É USADA</a:t>
             </a:r>
             <a:endParaRPr lang="en-US" sz="1050" dirty="0"/>
           </a:p>
@@ -13645,7 +13804,7 @@
                 <a:ea typeface="Calibri" pitchFamily="34" charset="-122"/>
                 <a:cs typeface="Calibri" pitchFamily="34" charset="-120"/>
               </a:rPr>
-              <a:t>Inicialização de pesos de redes neurais (Xavier, He)</a:t>
+              <a:t>Ajuste inicial de redes neurais</a:t>
             </a:r>
             <a:endParaRPr lang="en-US" sz="1350" dirty="0"/>
           </a:p>
@@ -13669,7 +13828,7 @@
                 <a:ea typeface="Calibri" pitchFamily="34" charset="-122"/>
                 <a:cs typeface="Calibri" pitchFamily="34" charset="-120"/>
               </a:rPr>
-              <a:t>Padronização de variáveis (z-score) antes do treino</a:t>
+              <a:t>Deixar variáveis na mesma escala</a:t>
             </a:r>
             <a:endParaRPr lang="en-US" sz="1350" dirty="0"/>
           </a:p>
@@ -13693,7 +13852,7 @@
                 <a:ea typeface="Calibri" pitchFamily="34" charset="-122"/>
                 <a:cs typeface="Calibri" pitchFamily="34" charset="-120"/>
               </a:rPr>
-              <a:t>Verossimilhança gaussiana no Naive Bayes</a:t>
+              <a:t>O modelo que usamos no próximo slide</a:t>
             </a:r>
             <a:endParaRPr lang="en-US" sz="1350" dirty="0"/>
           </a:p>
@@ -13717,7 +13876,7 @@
                 <a:ea typeface="Calibri" pitchFamily="34" charset="-122"/>
                 <a:cs typeface="Calibri" pitchFamily="34" charset="-120"/>
               </a:rPr>
-              <a:t>Detecção de anomalias acima de 3σ</a:t>
+              <a:t>Encontrar valores fora do normal</a:t>
             </a:r>
             <a:endParaRPr lang="en-US" sz="1350" dirty="0"/>
           </a:p>
@@ -13741,7 +13900,7 @@
                 <a:ea typeface="Calibri" pitchFamily="34" charset="-122"/>
                 <a:cs typeface="Calibri" pitchFamily="34" charset="-120"/>
               </a:rPr>
-              <a:t>Ruído gaussiano em modelos de difusão</a:t>
+              <a:t>Programas que geram imagens</a:t>
             </a:r>
             <a:endParaRPr lang="en-US" sz="1350" dirty="0"/>
           </a:p>
@@ -13765,7 +13924,7 @@
                 <a:ea typeface="Calibri" pitchFamily="34" charset="-122"/>
                 <a:cs typeface="Calibri" pitchFamily="34" charset="-120"/>
               </a:rPr>
-              <a:t>Intervalos de confiança das métricas do modelo</a:t>
+              <a:t>Margem de erro de pesquisas e testes</a:t>
             </a:r>
             <a:endParaRPr lang="en-US" sz="1350" dirty="0"/>
           </a:p>
@@ -13934,7 +14093,7 @@
                 <a:ea typeface="Calibri" pitchFamily="34" charset="-122"/>
                 <a:cs typeface="Calibri" pitchFamily="34" charset="-120"/>
               </a:rPr>
-              <a:t>Onde os dois temas se encontram: Bayes decide e a Normal calcula</a:t>
+              <a:t>O modelo que junta os dois temas</a:t>
             </a:r>
             <a:endParaRPr lang="en-US" sz="1400" dirty="0"/>
           </a:p>
@@ -13949,7 +14108,7 @@
         <p:spPr>
           <a:xfrm>
             <a:off x="566928" y="1536192"/>
-            <a:ext cx="5760720" cy="960120"/>
+            <a:ext cx="5760720" cy="1325880"/>
           </a:xfrm>
           <a:prstGeom prst="rect">
             <a:avLst/>
@@ -13976,7 +14135,7 @@
                 <a:ea typeface="Calibri" pitchFamily="34" charset="-122"/>
                 <a:cs typeface="Calibri" pitchFamily="34" charset="-120"/>
               </a:rPr>
-              <a:t>Para cada classe, o modelo estima a probabilidade a priori e uma curva Normal por variável. Diante de uma nova entrega, multiplica priori e verossimilhanças e escolhe a classe de maior probabilidade a posteriori.</a:t>
+              <a:t>O modelo aprende como é cada grupo, entregas no prazo e entregas atrasadas: distância média, quanto chove e quanto pega horário de pico. Diante de uma entrega nova, compara com os dois grupos, escolhe o mais parecido e diz em quantos por cento confia.</a:t>
             </a:r>
             <a:endParaRPr lang="en-US" sz="1400" dirty="0"/>
           </a:p>
@@ -13990,12 +14149,12 @@
         </p:nvSpPr>
         <p:spPr>
           <a:xfrm>
-            <a:off x="566928" y="2606040"/>
-            <a:ext cx="5760720" cy="713232"/>
+            <a:off x="566928" y="2971800"/>
+            <a:ext cx="5760720" cy="658368"/>
           </a:xfrm>
           <a:prstGeom prst="roundRect">
             <a:avLst>
-              <a:gd name="adj" fmla="val 10256"/>
+              <a:gd name="adj" fmla="val 11111"/>
             </a:avLst>
           </a:prstGeom>
           <a:solidFill>
@@ -14017,8 +14176,8 @@
         </p:nvSpPr>
         <p:spPr>
           <a:xfrm>
-            <a:off x="566928" y="2606040"/>
-            <a:ext cx="5760720" cy="713232"/>
+            <a:off x="566928" y="2971800"/>
+            <a:ext cx="5760720" cy="658368"/>
           </a:xfrm>
           <a:prstGeom prst="rect">
             <a:avLst/>
@@ -14034,7 +14193,7 @@
               <a:buNone/>
             </a:pPr>
             <a:r>
-              <a:rPr lang="en-US" sz="1600" b="1" dirty="0">
+              <a:rPr lang="en-US" sz="1500" b="1" dirty="0">
                 <a:solidFill>
                   <a:srgbClr val="FFFFFF"/>
                 </a:solidFill>
@@ -14042,9 +14201,9 @@
                 <a:ea typeface="Courier New" pitchFamily="34" charset="-122"/>
                 <a:cs typeface="Courier New" pitchFamily="34" charset="-120"/>
               </a:rPr>
-              <a:t>P(classe | x) ∝ P(classe) · Π P(xᵢ | classe)</a:t>
-            </a:r>
-            <a:endParaRPr lang="en-US" sz="1600" dirty="0"/>
+              <a:t>P(grupo | dados) = P(grupo) x P(dados | grupo)</a:t>
+            </a:r>
+            <a:endParaRPr lang="en-US" sz="1500" dirty="0"/>
           </a:p>
         </p:txBody>
       </p:sp>
@@ -14056,8 +14215,8 @@
         </p:nvSpPr>
         <p:spPr>
           <a:xfrm>
-            <a:off x="566928" y="3520440"/>
-            <a:ext cx="5760720" cy="2286000"/>
+            <a:off x="566928" y="3794760"/>
+            <a:ext cx="5760720" cy="2103120"/>
           </a:xfrm>
           <a:prstGeom prst="rect">
             <a:avLst/>
@@ -14088,7 +14247,7 @@
                 <a:ea typeface="Calibri" pitchFamily="34" charset="-122"/>
                 <a:cs typeface="Calibri" pitchFamily="34" charset="-120"/>
               </a:rPr>
-              <a:t>Treino com 70% da base: calcula P(classe), μ e σ de cada variável.</a:t>
+              <a:t>Treinamos com 70% das entregas e testamos nas outras 30%.</a:t>
             </a:r>
             <a:endParaRPr lang="en-US" sz="1400" dirty="0"/>
           </a:p>
@@ -14112,7 +14271,7 @@
                 <a:ea typeface="Calibri" pitchFamily="34" charset="-122"/>
                 <a:cs typeface="Calibri" pitchFamily="34" charset="-120"/>
               </a:rPr>
-              <a:t>O termo “naive” vem da suposição de independência entre as variáveis.</a:t>
+              <a:t>O nome “naive”, ingênuo, vem de tratar as colunas como independentes.</a:t>
             </a:r>
             <a:endParaRPr lang="en-US" sz="1400" dirty="0"/>
           </a:p>
@@ -14136,7 +14295,7 @@
                 <a:ea typeface="Calibri" pitchFamily="34" charset="-122"/>
                 <a:cs typeface="Calibri" pitchFamily="34" charset="-120"/>
               </a:rPr>
-              <a:t>A verossimilhança contínua usa a densidade da Normal na distância.</a:t>
+              <a:t>A curva Normal entra para medir o quanto a distância combina com cada grupo.</a:t>
             </a:r>
             <a:endParaRPr lang="en-US" sz="1400" dirty="0"/>
           </a:p>
@@ -14160,7 +14319,7 @@
                 <a:ea typeface="Calibri" pitchFamily="34" charset="-122"/>
                 <a:cs typeface="Calibri" pitchFamily="34" charset="-120"/>
               </a:rPr>
-              <a:t>A saída é uma probabilidade, e não apenas um rótulo.</a:t>
+              <a:t>A resposta vem em porcentagem, não só um sim ou não.</a:t>
             </a:r>
             <a:endParaRPr lang="en-US" sz="1400" dirty="0"/>
           </a:p>
@@ -14475,7 +14634,7 @@
                 <a:ea typeface="Calibri" pitchFamily="34" charset="-122"/>
                 <a:cs typeface="Calibri" pitchFamily="34" charset="-120"/>
               </a:rPr>
-              <a:t>Nenhuma biblioteca de machine learning foi usada. O modelo usa apenas probabilidade e a fórmula da Normal.</a:t>
+              <a:t>É o mesmo raciocínio de olhar uma fruta e dizer se é laranja ou limão pelo tamanho e pela cor: comparamos com o que já vimos antes de cada uma.</a:t>
             </a:r>
             <a:endParaRPr lang="en-US" sz="1200" dirty="0"/>
           </a:p>

</xml_diff>